<commit_message>
deck: the closing slide does one job
It was carrying four metric chips that the title slide already showed, and a
note about the repository sitting under somebody's name as if it were their
title. A closing slide thanks the room, leaves the one line worth
remembering, and says where to check the numbers. That is all it does now.
</commit_message>
<xml_diff>
--- a/docs/deck-editable/MeshAI_Deck.pptx
+++ b/docs/deck-editable/MeshAI_Deck.pptx
@@ -16177,8 +16177,8 @@
         </p:nvSpPr>
         <p:spPr>
           <a:xfrm>
-            <a:off x="9753356" y="3154680"/>
-            <a:ext cx="2377440" cy="0"/>
+            <a:off x="9753356" y="3291840"/>
+            <a:ext cx="2468880" cy="0"/>
           </a:xfrm>
           <a:custGeom>
             <a:avLst/>
@@ -16187,12 +16187,12 @@
             <a:cxnLst/>
             <a:rect l="l" t="t" r="r" b="b"/>
             <a:pathLst>
-              <a:path w="2377440" h="0">
+              <a:path w="2468880" h="0">
                 <a:moveTo>
                   <a:pt x="0" y="0"/>
                 </a:moveTo>
                 <a:lnTo>
-                  <a:pt x="2377440" y="0"/>
+                  <a:pt x="2468880" y="0"/>
                 </a:lnTo>
               </a:path>
             </a:pathLst>
@@ -16235,8 +16235,8 @@
         </p:nvSpPr>
         <p:spPr>
           <a:xfrm>
-            <a:off x="9753356" y="3154680"/>
-            <a:ext cx="2058923" cy="1188720"/>
+            <a:off x="9753356" y="3291840"/>
+            <a:ext cx="2138112" cy="1234440"/>
           </a:xfrm>
           <a:custGeom>
             <a:avLst/>
@@ -16245,12 +16245,12 @@
             <a:cxnLst/>
             <a:rect l="l" t="t" r="r" b="b"/>
             <a:pathLst>
-              <a:path w="2058923" h="1188720">
+              <a:path w="2138112" h="1234440">
                 <a:moveTo>
                   <a:pt x="0" y="0"/>
                 </a:moveTo>
                 <a:lnTo>
-                  <a:pt x="2058923" y="1188720"/>
+                  <a:pt x="2138112" y="1234440"/>
                 </a:lnTo>
               </a:path>
             </a:pathLst>
@@ -16293,8 +16293,8 @@
         </p:nvSpPr>
         <p:spPr>
           <a:xfrm>
-            <a:off x="9753356" y="3154680"/>
-            <a:ext cx="1188720" cy="2058923"/>
+            <a:off x="9753356" y="3291840"/>
+            <a:ext cx="1234440" cy="2138112"/>
           </a:xfrm>
           <a:custGeom>
             <a:avLst/>
@@ -16303,12 +16303,12 @@
             <a:cxnLst/>
             <a:rect l="l" t="t" r="r" b="b"/>
             <a:pathLst>
-              <a:path w="1188720" h="2058923">
+              <a:path w="1234440" h="2138112">
                 <a:moveTo>
                   <a:pt x="0" y="0"/>
                 </a:moveTo>
                 <a:lnTo>
-                  <a:pt x="1188720" y="2058923"/>
+                  <a:pt x="1234440" y="2138112"/>
                 </a:lnTo>
               </a:path>
             </a:pathLst>
@@ -16351,8 +16351,8 @@
         </p:nvSpPr>
         <p:spPr>
           <a:xfrm>
-            <a:off x="9753356" y="3154680"/>
-            <a:ext cx="0" cy="2377440"/>
+            <a:off x="9753356" y="3291840"/>
+            <a:ext cx="0" cy="2468880"/>
           </a:xfrm>
           <a:custGeom>
             <a:avLst/>
@@ -16361,12 +16361,12 @@
             <a:cxnLst/>
             <a:rect l="l" t="t" r="r" b="b"/>
             <a:pathLst>
-              <a:path w="0" h="2377440">
+              <a:path w="0" h="2468880">
                 <a:moveTo>
                   <a:pt x="0" y="0"/>
                 </a:moveTo>
                 <a:lnTo>
-                  <a:pt x="0" y="2377440"/>
+                  <a:pt x="0" y="2468880"/>
                 </a:lnTo>
               </a:path>
             </a:pathLst>
@@ -16409,8 +16409,8 @@
         </p:nvSpPr>
         <p:spPr>
           <a:xfrm>
-            <a:off x="8564636" y="3154680"/>
-            <a:ext cx="1188720" cy="2058923"/>
+            <a:off x="8518916" y="3291840"/>
+            <a:ext cx="1234440" cy="2138112"/>
           </a:xfrm>
           <a:custGeom>
             <a:avLst/>
@@ -16419,12 +16419,12 @@
             <a:cxnLst/>
             <a:rect l="l" t="t" r="r" b="b"/>
             <a:pathLst>
-              <a:path w="1188720" h="2058923">
+              <a:path w="1234440" h="2138112">
                 <a:moveTo>
-                  <a:pt x="1188720" y="0"/>
+                  <a:pt x="1234440" y="0"/>
                 </a:moveTo>
                 <a:lnTo>
-                  <a:pt x="0" y="2058923"/>
+                  <a:pt x="0" y="2138112"/>
                 </a:lnTo>
               </a:path>
             </a:pathLst>
@@ -16467,8 +16467,8 @@
         </p:nvSpPr>
         <p:spPr>
           <a:xfrm>
-            <a:off x="7694432" y="3154680"/>
-            <a:ext cx="2058924" cy="1188720"/>
+            <a:off x="7615243" y="3291840"/>
+            <a:ext cx="2138113" cy="1234440"/>
           </a:xfrm>
           <a:custGeom>
             <a:avLst/>
@@ -16477,12 +16477,12 @@
             <a:cxnLst/>
             <a:rect l="l" t="t" r="r" b="b"/>
             <a:pathLst>
-              <a:path w="2058924" h="1188720">
+              <a:path w="2138113" h="1234440">
                 <a:moveTo>
-                  <a:pt x="2058924" y="0"/>
+                  <a:pt x="2138113" y="0"/>
                 </a:moveTo>
                 <a:lnTo>
-                  <a:pt x="0" y="1188720"/>
+                  <a:pt x="0" y="1234440"/>
                 </a:lnTo>
               </a:path>
             </a:pathLst>
@@ -16525,8 +16525,8 @@
         </p:nvSpPr>
         <p:spPr>
           <a:xfrm>
-            <a:off x="7375916" y="3154680"/>
-            <a:ext cx="2377440" cy="0"/>
+            <a:off x="7284476" y="3291840"/>
+            <a:ext cx="2468880" cy="0"/>
           </a:xfrm>
           <a:custGeom>
             <a:avLst/>
@@ -16535,9 +16535,9 @@
             <a:cxnLst/>
             <a:rect l="l" t="t" r="r" b="b"/>
             <a:pathLst>
-              <a:path w="2377440" h="0">
+              <a:path w="2468880" h="0">
                 <a:moveTo>
-                  <a:pt x="2377440" y="0"/>
+                  <a:pt x="2468880" y="0"/>
                 </a:moveTo>
                 <a:lnTo>
                   <a:pt x="0" y="0"/>
@@ -16583,8 +16583,8 @@
         </p:nvSpPr>
         <p:spPr>
           <a:xfrm>
-            <a:off x="7694432" y="1965960"/>
-            <a:ext cx="2058924" cy="1188720"/>
+            <a:off x="7615243" y="2057400"/>
+            <a:ext cx="2138113" cy="1234440"/>
           </a:xfrm>
           <a:custGeom>
             <a:avLst/>
@@ -16593,9 +16593,9 @@
             <a:cxnLst/>
             <a:rect l="l" t="t" r="r" b="b"/>
             <a:pathLst>
-              <a:path w="2058924" h="1188720">
+              <a:path w="2138113" h="1234440">
                 <a:moveTo>
-                  <a:pt x="2058924" y="1188720"/>
+                  <a:pt x="2138113" y="1234440"/>
                 </a:moveTo>
                 <a:lnTo>
                   <a:pt x="0" y="0"/>
@@ -16641,8 +16641,8 @@
         </p:nvSpPr>
         <p:spPr>
           <a:xfrm>
-            <a:off x="8564635" y="1095756"/>
-            <a:ext cx="1188721" cy="2058924"/>
+            <a:off x="8518915" y="1153727"/>
+            <a:ext cx="1234441" cy="2138113"/>
           </a:xfrm>
           <a:custGeom>
             <a:avLst/>
@@ -16651,9 +16651,9 @@
             <a:cxnLst/>
             <a:rect l="l" t="t" r="r" b="b"/>
             <a:pathLst>
-              <a:path w="1188721" h="2058924">
+              <a:path w="1234441" h="2138113">
                 <a:moveTo>
-                  <a:pt x="1188721" y="2058924"/>
+                  <a:pt x="1234441" y="2138113"/>
                 </a:moveTo>
                 <a:lnTo>
                   <a:pt x="0" y="0"/>
@@ -16699,8 +16699,8 @@
         </p:nvSpPr>
         <p:spPr>
           <a:xfrm>
-            <a:off x="9753356" y="777240"/>
-            <a:ext cx="0" cy="2377440"/>
+            <a:off x="9753356" y="822960"/>
+            <a:ext cx="0" cy="2468880"/>
           </a:xfrm>
           <a:custGeom>
             <a:avLst/>
@@ -16709,9 +16709,9 @@
             <a:cxnLst/>
             <a:rect l="l" t="t" r="r" b="b"/>
             <a:pathLst>
-              <a:path w="0" h="2377440">
+              <a:path w="0" h="2468880">
                 <a:moveTo>
-                  <a:pt x="0" y="2377440"/>
+                  <a:pt x="0" y="2468880"/>
                 </a:moveTo>
                 <a:lnTo>
                   <a:pt x="0" y="0"/>
@@ -16757,8 +16757,8 @@
         </p:nvSpPr>
         <p:spPr>
           <a:xfrm>
-            <a:off x="9753356" y="1095756"/>
-            <a:ext cx="1188720" cy="2058924"/>
+            <a:off x="9753356" y="1153727"/>
+            <a:ext cx="1234440" cy="2138113"/>
           </a:xfrm>
           <a:custGeom>
             <a:avLst/>
@@ -16767,12 +16767,12 @@
             <a:cxnLst/>
             <a:rect l="l" t="t" r="r" b="b"/>
             <a:pathLst>
-              <a:path w="1188720" h="2058924">
+              <a:path w="1234440" h="2138113">
                 <a:moveTo>
-                  <a:pt x="0" y="2058924"/>
+                  <a:pt x="0" y="2138113"/>
                 </a:moveTo>
                 <a:lnTo>
-                  <a:pt x="1188720" y="0"/>
+                  <a:pt x="1234440" y="0"/>
                 </a:lnTo>
               </a:path>
             </a:pathLst>
@@ -16815,8 +16815,8 @@
         </p:nvSpPr>
         <p:spPr>
           <a:xfrm>
-            <a:off x="9753356" y="1965959"/>
-            <a:ext cx="2058923" cy="1188721"/>
+            <a:off x="9753356" y="2057399"/>
+            <a:ext cx="2138112" cy="1234441"/>
           </a:xfrm>
           <a:custGeom>
             <a:avLst/>
@@ -16825,12 +16825,12 @@
             <a:cxnLst/>
             <a:rect l="l" t="t" r="r" b="b"/>
             <a:pathLst>
-              <a:path w="2058923" h="1188721">
+              <a:path w="2138112" h="1234441">
                 <a:moveTo>
-                  <a:pt x="0" y="1188721"/>
+                  <a:pt x="0" y="1234441"/>
                 </a:moveTo>
                 <a:lnTo>
-                  <a:pt x="2058923" y="0"/>
+                  <a:pt x="2138112" y="0"/>
                 </a:lnTo>
               </a:path>
             </a:pathLst>
@@ -16873,8 +16873,8 @@
         </p:nvSpPr>
         <p:spPr>
           <a:xfrm>
-            <a:off x="9158996" y="2560320"/>
-            <a:ext cx="1188720" cy="1188720"/>
+            <a:off x="9136136" y="2674620"/>
+            <a:ext cx="1234440" cy="1234440"/>
           </a:xfrm>
           <a:custGeom>
             <a:avLst/>
@@ -16883,45 +16883,45 @@
             <a:cxnLst/>
             <a:rect l="l" t="t" r="r" b="b"/>
             <a:pathLst>
-              <a:path w="1188720" h="1188720">
+              <a:path w="1234440" h="1234440">
                 <a:moveTo>
-                  <a:pt x="1188720" y="594360"/>
+                  <a:pt x="1234440" y="617220"/>
                 </a:moveTo>
                 <a:lnTo>
-                  <a:pt x="1109090" y="891540"/>
-                </a:lnTo>
-                <a:lnTo>
-                  <a:pt x="891540" y="1109090"/>
-                </a:lnTo>
-                <a:lnTo>
-                  <a:pt x="594360" y="1188720"/>
-                </a:lnTo>
-                <a:lnTo>
-                  <a:pt x="297180" y="1109090"/>
-                </a:lnTo>
-                <a:lnTo>
-                  <a:pt x="79629" y="891540"/>
-                </a:lnTo>
-                <a:lnTo>
-                  <a:pt x="0" y="594360"/>
-                </a:lnTo>
-                <a:lnTo>
-                  <a:pt x="79629" y="297180"/>
-                </a:lnTo>
-                <a:lnTo>
-                  <a:pt x="297180" y="79629"/>
-                </a:lnTo>
-                <a:lnTo>
-                  <a:pt x="594360" y="0"/>
-                </a:lnTo>
-                <a:lnTo>
-                  <a:pt x="891540" y="79629"/>
-                </a:lnTo>
-                <a:lnTo>
-                  <a:pt x="1109090" y="297179"/>
-                </a:lnTo>
-                <a:lnTo>
-                  <a:pt x="1188720" y="594360"/>
+                  <a:pt x="1151748" y="925830"/>
+                </a:lnTo>
+                <a:lnTo>
+                  <a:pt x="925830" y="1151748"/>
+                </a:lnTo>
+                <a:lnTo>
+                  <a:pt x="617220" y="1234440"/>
+                </a:lnTo>
+                <a:lnTo>
+                  <a:pt x="308610" y="1151748"/>
+                </a:lnTo>
+                <a:lnTo>
+                  <a:pt x="82691" y="925830"/>
+                </a:lnTo>
+                <a:lnTo>
+                  <a:pt x="0" y="617220"/>
+                </a:lnTo>
+                <a:lnTo>
+                  <a:pt x="82691" y="308610"/>
+                </a:lnTo>
+                <a:lnTo>
+                  <a:pt x="308610" y="82691"/>
+                </a:lnTo>
+                <a:lnTo>
+                  <a:pt x="617220" y="0"/>
+                </a:lnTo>
+                <a:lnTo>
+                  <a:pt x="925830" y="82691"/>
+                </a:lnTo>
+                <a:lnTo>
+                  <a:pt x="1151748" y="308609"/>
+                </a:lnTo>
+                <a:lnTo>
+                  <a:pt x="1234440" y="617220"/>
                 </a:lnTo>
                 <a:close/>
               </a:path>
@@ -16965,8 +16965,8 @@
         </p:nvSpPr>
         <p:spPr>
           <a:xfrm>
-            <a:off x="8564636" y="1965960"/>
-            <a:ext cx="2377440" cy="2377440"/>
+            <a:off x="8518916" y="2057400"/>
+            <a:ext cx="2468880" cy="2468880"/>
           </a:xfrm>
           <a:custGeom>
             <a:avLst/>
@@ -16975,45 +16975,45 @@
             <a:cxnLst/>
             <a:rect l="l" t="t" r="r" b="b"/>
             <a:pathLst>
-              <a:path w="2377440" h="2377440">
+              <a:path w="2468880" h="2468880">
                 <a:moveTo>
-                  <a:pt x="2377440" y="1188720"/>
+                  <a:pt x="2468880" y="1234440"/>
                 </a:moveTo>
                 <a:lnTo>
-                  <a:pt x="2218181" y="1783080"/>
-                </a:lnTo>
-                <a:lnTo>
-                  <a:pt x="1783080" y="2218181"/>
-                </a:lnTo>
-                <a:lnTo>
-                  <a:pt x="1188720" y="2377440"/>
-                </a:lnTo>
-                <a:lnTo>
-                  <a:pt x="594360" y="2218181"/>
-                </a:lnTo>
-                <a:lnTo>
-                  <a:pt x="159258" y="1783080"/>
-                </a:lnTo>
-                <a:lnTo>
-                  <a:pt x="0" y="1188720"/>
-                </a:lnTo>
-                <a:lnTo>
-                  <a:pt x="159258" y="594360"/>
-                </a:lnTo>
-                <a:lnTo>
-                  <a:pt x="594360" y="159258"/>
-                </a:lnTo>
-                <a:lnTo>
-                  <a:pt x="1188720" y="0"/>
-                </a:lnTo>
-                <a:lnTo>
-                  <a:pt x="1783080" y="159258"/>
-                </a:lnTo>
-                <a:lnTo>
-                  <a:pt x="2218181" y="594359"/>
-                </a:lnTo>
-                <a:lnTo>
-                  <a:pt x="2377440" y="1188719"/>
+                  <a:pt x="2303496" y="1851660"/>
+                </a:lnTo>
+                <a:lnTo>
+                  <a:pt x="1851660" y="2303496"/>
+                </a:lnTo>
+                <a:lnTo>
+                  <a:pt x="1234440" y="2468880"/>
+                </a:lnTo>
+                <a:lnTo>
+                  <a:pt x="617220" y="2303496"/>
+                </a:lnTo>
+                <a:lnTo>
+                  <a:pt x="165383" y="1851660"/>
+                </a:lnTo>
+                <a:lnTo>
+                  <a:pt x="0" y="1234440"/>
+                </a:lnTo>
+                <a:lnTo>
+                  <a:pt x="165383" y="617220"/>
+                </a:lnTo>
+                <a:lnTo>
+                  <a:pt x="617220" y="165383"/>
+                </a:lnTo>
+                <a:lnTo>
+                  <a:pt x="1234440" y="0"/>
+                </a:lnTo>
+                <a:lnTo>
+                  <a:pt x="1851660" y="165383"/>
+                </a:lnTo>
+                <a:lnTo>
+                  <a:pt x="2303496" y="617219"/>
+                </a:lnTo>
+                <a:lnTo>
+                  <a:pt x="2468880" y="1234439"/>
                 </a:lnTo>
                 <a:close/>
               </a:path>
@@ -17057,8 +17057,8 @@
         </p:nvSpPr>
         <p:spPr>
           <a:xfrm>
-            <a:off x="7970276" y="1371600"/>
-            <a:ext cx="3566160" cy="3566160"/>
+            <a:off x="7901696" y="1440180"/>
+            <a:ext cx="3703320" cy="3703320"/>
           </a:xfrm>
           <a:custGeom>
             <a:avLst/>
@@ -17067,45 +17067,45 @@
             <a:cxnLst/>
             <a:rect l="l" t="t" r="r" b="b"/>
             <a:pathLst>
-              <a:path w="3566160" h="3566160">
+              <a:path w="3703320" h="3703320">
                 <a:moveTo>
-                  <a:pt x="3566160" y="1783080"/>
+                  <a:pt x="3703320" y="1851660"/>
                 </a:moveTo>
                 <a:lnTo>
-                  <a:pt x="3327272" y="2674620"/>
-                </a:lnTo>
-                <a:lnTo>
-                  <a:pt x="2674620" y="3327272"/>
-                </a:lnTo>
-                <a:lnTo>
-                  <a:pt x="1783080" y="3566160"/>
-                </a:lnTo>
-                <a:lnTo>
-                  <a:pt x="891540" y="3327272"/>
-                </a:lnTo>
-                <a:lnTo>
-                  <a:pt x="238887" y="2674620"/>
-                </a:lnTo>
-                <a:lnTo>
-                  <a:pt x="0" y="1783080"/>
-                </a:lnTo>
-                <a:lnTo>
-                  <a:pt x="238887" y="891540"/>
-                </a:lnTo>
-                <a:lnTo>
-                  <a:pt x="891540" y="238887"/>
-                </a:lnTo>
-                <a:lnTo>
-                  <a:pt x="1783080" y="0"/>
-                </a:lnTo>
-                <a:lnTo>
-                  <a:pt x="2674620" y="238887"/>
-                </a:lnTo>
-                <a:lnTo>
-                  <a:pt x="3327272" y="891539"/>
-                </a:lnTo>
-                <a:lnTo>
-                  <a:pt x="3566160" y="1783079"/>
+                  <a:pt x="3455244" y="2777490"/>
+                </a:lnTo>
+                <a:lnTo>
+                  <a:pt x="2777490" y="3455244"/>
+                </a:lnTo>
+                <a:lnTo>
+                  <a:pt x="1851660" y="3703320"/>
+                </a:lnTo>
+                <a:lnTo>
+                  <a:pt x="925830" y="3455244"/>
+                </a:lnTo>
+                <a:lnTo>
+                  <a:pt x="248075" y="2777490"/>
+                </a:lnTo>
+                <a:lnTo>
+                  <a:pt x="0" y="1851660"/>
+                </a:lnTo>
+                <a:lnTo>
+                  <a:pt x="248075" y="925830"/>
+                </a:lnTo>
+                <a:lnTo>
+                  <a:pt x="925830" y="248075"/>
+                </a:lnTo>
+                <a:lnTo>
+                  <a:pt x="1851660" y="0"/>
+                </a:lnTo>
+                <a:lnTo>
+                  <a:pt x="2777490" y="248075"/>
+                </a:lnTo>
+                <a:lnTo>
+                  <a:pt x="3455244" y="925829"/>
+                </a:lnTo>
+                <a:lnTo>
+                  <a:pt x="3703320" y="1851659"/>
                 </a:lnTo>
                 <a:close/>
               </a:path>
@@ -17149,8 +17149,8 @@
         </p:nvSpPr>
         <p:spPr>
           <a:xfrm>
-            <a:off x="7375916" y="777240"/>
-            <a:ext cx="4754880" cy="4754880"/>
+            <a:off x="7284476" y="822960"/>
+            <a:ext cx="4937760" cy="4937760"/>
           </a:xfrm>
           <a:custGeom>
             <a:avLst/>
@@ -17159,45 +17159,45 @@
             <a:cxnLst/>
             <a:rect l="l" t="t" r="r" b="b"/>
             <a:pathLst>
-              <a:path w="4754880" h="4754880">
+              <a:path w="4937760" h="4937760">
                 <a:moveTo>
-                  <a:pt x="4754880" y="2377440"/>
+                  <a:pt x="4937760" y="2468880"/>
                 </a:moveTo>
                 <a:lnTo>
-                  <a:pt x="4436363" y="3566160"/>
-                </a:lnTo>
-                <a:lnTo>
-                  <a:pt x="3566160" y="4436363"/>
-                </a:lnTo>
-                <a:lnTo>
-                  <a:pt x="2377440" y="4754880"/>
-                </a:lnTo>
-                <a:lnTo>
-                  <a:pt x="1188720" y="4436363"/>
-                </a:lnTo>
-                <a:lnTo>
-                  <a:pt x="318516" y="3566160"/>
-                </a:lnTo>
-                <a:lnTo>
-                  <a:pt x="0" y="2377440"/>
-                </a:lnTo>
-                <a:lnTo>
-                  <a:pt x="318516" y="1188720"/>
-                </a:lnTo>
-                <a:lnTo>
-                  <a:pt x="1188719" y="318516"/>
-                </a:lnTo>
-                <a:lnTo>
-                  <a:pt x="2377440" y="0"/>
-                </a:lnTo>
-                <a:lnTo>
-                  <a:pt x="3566160" y="318516"/>
-                </a:lnTo>
-                <a:lnTo>
-                  <a:pt x="4436363" y="1188719"/>
-                </a:lnTo>
-                <a:lnTo>
-                  <a:pt x="4754880" y="2377439"/>
+                  <a:pt x="4606992" y="3703320"/>
+                </a:lnTo>
+                <a:lnTo>
+                  <a:pt x="3703320" y="4606992"/>
+                </a:lnTo>
+                <a:lnTo>
+                  <a:pt x="2468880" y="4937760"/>
+                </a:lnTo>
+                <a:lnTo>
+                  <a:pt x="1234440" y="4606992"/>
+                </a:lnTo>
+                <a:lnTo>
+                  <a:pt x="330767" y="3703320"/>
+                </a:lnTo>
+                <a:lnTo>
+                  <a:pt x="0" y="2468880"/>
+                </a:lnTo>
+                <a:lnTo>
+                  <a:pt x="330767" y="1234440"/>
+                </a:lnTo>
+                <a:lnTo>
+                  <a:pt x="1234439" y="330767"/>
+                </a:lnTo>
+                <a:lnTo>
+                  <a:pt x="2468880" y="0"/>
+                </a:lnTo>
+                <a:lnTo>
+                  <a:pt x="3703320" y="330767"/>
+                </a:lnTo>
+                <a:lnTo>
+                  <a:pt x="4606992" y="1234439"/>
+                </a:lnTo>
+                <a:lnTo>
+                  <a:pt x="4937760" y="2468879"/>
                 </a:lnTo>
                 <a:close/>
               </a:path>
@@ -17241,8 +17241,8 @@
         </p:nvSpPr>
         <p:spPr>
           <a:xfrm>
-            <a:off x="9240390" y="2691724"/>
-            <a:ext cx="512966" cy="462956"/>
+            <a:off x="9210216" y="2801651"/>
+            <a:ext cx="543140" cy="490189"/>
           </a:xfrm>
           <a:custGeom>
             <a:avLst/>
@@ -17251,15 +17251,15 @@
             <a:cxnLst/>
             <a:rect l="l" t="t" r="r" b="b"/>
             <a:pathLst>
-              <a:path w="512966" h="462956">
+              <a:path w="543140" h="490189">
                 <a:moveTo>
-                  <a:pt x="512966" y="462956"/>
+                  <a:pt x="543140" y="490189"/>
                 </a:moveTo>
                 <a:lnTo>
-                  <a:pt x="205186" y="0"/>
-                </a:lnTo>
-                <a:lnTo>
-                  <a:pt x="0" y="135719"/>
+                  <a:pt x="217256" y="0"/>
+                </a:lnTo>
+                <a:lnTo>
+                  <a:pt x="0" y="143702"/>
                 </a:lnTo>
               </a:path>
             </a:pathLst>
@@ -17302,8 +17302,8 @@
         </p:nvSpPr>
         <p:spPr>
           <a:xfrm>
-            <a:off x="9004274" y="2880030"/>
-            <a:ext cx="749082" cy="274650"/>
+            <a:off x="8960211" y="3001034"/>
+            <a:ext cx="793145" cy="290806"/>
           </a:xfrm>
           <a:custGeom>
             <a:avLst/>
@@ -17312,15 +17312,15 @@
             <a:cxnLst/>
             <a:rect l="l" t="t" r="r" b="b"/>
             <a:pathLst>
-              <a:path w="749082" h="274650">
+              <a:path w="793145" h="290806">
                 <a:moveTo>
-                  <a:pt x="749082" y="274650"/>
+                  <a:pt x="793145" y="290806"/>
                 </a:moveTo>
                 <a:lnTo>
-                  <a:pt x="299633" y="0"/>
-                </a:lnTo>
-                <a:lnTo>
-                  <a:pt x="0" y="248701"/>
+                  <a:pt x="317258" y="0"/>
+                </a:lnTo>
+                <a:lnTo>
+                  <a:pt x="0" y="263331"/>
                 </a:lnTo>
               </a:path>
             </a:pathLst>
@@ -17363,8 +17363,8 @@
         </p:nvSpPr>
         <p:spPr>
           <a:xfrm>
-            <a:off x="9013164" y="3102239"/>
-            <a:ext cx="740192" cy="382027"/>
+            <a:off x="8969623" y="3236314"/>
+            <a:ext cx="783733" cy="404499"/>
           </a:xfrm>
           <a:custGeom>
             <a:avLst/>
@@ -17373,15 +17373,15 @@
             <a:cxnLst/>
             <a:rect l="l" t="t" r="r" b="b"/>
             <a:pathLst>
-              <a:path w="740192" h="382027">
+              <a:path w="783733" h="404499">
                 <a:moveTo>
-                  <a:pt x="740192" y="52441"/>
+                  <a:pt x="783733" y="55526"/>
                 </a:moveTo>
                 <a:lnTo>
-                  <a:pt x="296076" y="0"/>
-                </a:lnTo>
-                <a:lnTo>
-                  <a:pt x="0" y="382027"/>
+                  <a:pt x="313493" y="0"/>
+                </a:lnTo>
+                <a:lnTo>
+                  <a:pt x="0" y="404499"/>
                 </a:lnTo>
               </a:path>
             </a:pathLst>
@@ -17424,8 +17424,8 @@
         </p:nvSpPr>
         <p:spPr>
           <a:xfrm>
-            <a:off x="9264151" y="3154680"/>
-            <a:ext cx="489205" cy="623080"/>
+            <a:off x="9235375" y="3291840"/>
+            <a:ext cx="517981" cy="659731"/>
           </a:xfrm>
           <a:custGeom>
             <a:avLst/>
@@ -17434,15 +17434,15 @@
             <a:cxnLst/>
             <a:rect l="l" t="t" r="r" b="b"/>
             <a:pathLst>
-              <a:path w="489205" h="623080">
+              <a:path w="517981" h="659731">
                 <a:moveTo>
-                  <a:pt x="489205" y="0"/>
+                  <a:pt x="517981" y="0"/>
                 </a:moveTo>
                 <a:lnTo>
-                  <a:pt x="195682" y="130992"/>
-                </a:lnTo>
-                <a:lnTo>
-                  <a:pt x="0" y="623080"/>
+                  <a:pt x="207192" y="138698"/>
+                </a:lnTo>
+                <a:lnTo>
+                  <a:pt x="0" y="659731"/>
                 </a:lnTo>
               </a:path>
             </a:pathLst>
@@ -17485,8 +17485,8 @@
         </p:nvSpPr>
         <p:spPr>
           <a:xfrm>
-            <a:off x="9753356" y="2691724"/>
-            <a:ext cx="512965" cy="462956"/>
+            <a:off x="9753356" y="2801651"/>
+            <a:ext cx="543139" cy="490189"/>
           </a:xfrm>
           <a:custGeom>
             <a:avLst/>
@@ -17495,15 +17495,15 @@
             <a:cxnLst/>
             <a:rect l="l" t="t" r="r" b="b"/>
             <a:pathLst>
-              <a:path w="512965" h="462956">
+              <a:path w="543139" h="490189">
                 <a:moveTo>
-                  <a:pt x="0" y="462956"/>
+                  <a:pt x="0" y="490189"/>
                 </a:moveTo>
                 <a:lnTo>
-                  <a:pt x="307779" y="0"/>
-                </a:lnTo>
-                <a:lnTo>
-                  <a:pt x="512965" y="135719"/>
+                  <a:pt x="325883" y="0"/>
+                </a:lnTo>
+                <a:lnTo>
+                  <a:pt x="543139" y="143702"/>
                 </a:lnTo>
               </a:path>
             </a:pathLst>
@@ -17546,8 +17546,8 @@
         </p:nvSpPr>
         <p:spPr>
           <a:xfrm>
-            <a:off x="9753356" y="2880030"/>
-            <a:ext cx="749081" cy="274650"/>
+            <a:off x="9753356" y="3001034"/>
+            <a:ext cx="793144" cy="290806"/>
           </a:xfrm>
           <a:custGeom>
             <a:avLst/>
@@ -17556,15 +17556,15 @@
             <a:cxnLst/>
             <a:rect l="l" t="t" r="r" b="b"/>
             <a:pathLst>
-              <a:path w="749081" h="274650">
+              <a:path w="793144" h="290806">
                 <a:moveTo>
-                  <a:pt x="0" y="274650"/>
+                  <a:pt x="0" y="290806"/>
                 </a:moveTo>
                 <a:lnTo>
-                  <a:pt x="449448" y="0"/>
-                </a:lnTo>
-                <a:lnTo>
-                  <a:pt x="749081" y="248701"/>
+                  <a:pt x="475886" y="0"/>
+                </a:lnTo>
+                <a:lnTo>
+                  <a:pt x="793144" y="263331"/>
                 </a:lnTo>
               </a:path>
             </a:pathLst>
@@ -17607,8 +17607,8 @@
         </p:nvSpPr>
         <p:spPr>
           <a:xfrm>
-            <a:off x="9753356" y="3102239"/>
-            <a:ext cx="740191" cy="382027"/>
+            <a:off x="9753356" y="3236314"/>
+            <a:ext cx="783732" cy="404499"/>
           </a:xfrm>
           <a:custGeom>
             <a:avLst/>
@@ -17617,15 +17617,15 @@
             <a:cxnLst/>
             <a:rect l="l" t="t" r="r" b="b"/>
             <a:pathLst>
-              <a:path w="740191" h="382027">
+              <a:path w="783732" h="404499">
                 <a:moveTo>
-                  <a:pt x="0" y="52441"/>
+                  <a:pt x="0" y="55526"/>
                 </a:moveTo>
                 <a:lnTo>
-                  <a:pt x="444115" y="0"/>
-                </a:lnTo>
-                <a:lnTo>
-                  <a:pt x="740191" y="382027"/>
+                  <a:pt x="470239" y="0"/>
+                </a:lnTo>
+                <a:lnTo>
+                  <a:pt x="783732" y="404499"/>
                 </a:lnTo>
               </a:path>
             </a:pathLst>
@@ -17668,8 +17668,8 @@
         </p:nvSpPr>
         <p:spPr>
           <a:xfrm>
-            <a:off x="9753356" y="3154680"/>
-            <a:ext cx="489204" cy="623080"/>
+            <a:off x="9753356" y="3291840"/>
+            <a:ext cx="517980" cy="659731"/>
           </a:xfrm>
           <a:custGeom>
             <a:avLst/>
@@ -17678,15 +17678,15 @@
             <a:cxnLst/>
             <a:rect l="l" t="t" r="r" b="b"/>
             <a:pathLst>
-              <a:path w="489204" h="623080">
+              <a:path w="517980" h="659731">
                 <a:moveTo>
                   <a:pt x="0" y="0"/>
                 </a:moveTo>
                 <a:lnTo>
-                  <a:pt x="293522" y="130992"/>
-                </a:lnTo>
-                <a:lnTo>
-                  <a:pt x="489204" y="623080"/>
+                  <a:pt x="310788" y="138698"/>
+                </a:lnTo>
+                <a:lnTo>
+                  <a:pt x="517980" y="659731"/>
                 </a:lnTo>
               </a:path>
             </a:pathLst>
@@ -17729,8 +17729,8 @@
         </p:nvSpPr>
         <p:spPr>
           <a:xfrm>
-            <a:off x="9489094" y="3014776"/>
-            <a:ext cx="528523" cy="528523"/>
+            <a:off x="9473549" y="3143707"/>
+            <a:ext cx="559612" cy="559612"/>
           </a:xfrm>
           <a:prstGeom prst="ellipse">
             <a:avLst/>
@@ -17773,8 +17773,8 @@
         </p:nvSpPr>
         <p:spPr>
           <a:xfrm>
-            <a:off x="9591690" y="2759842"/>
-            <a:ext cx="323331" cy="323331"/>
+            <a:off x="9582180" y="2873776"/>
+            <a:ext cx="342351" cy="342351"/>
           </a:xfrm>
           <a:prstGeom prst="ellipse">
             <a:avLst/>
@@ -17817,8 +17817,8 @@
         </p:nvSpPr>
         <p:spPr>
           <a:xfrm>
-            <a:off x="566928" y="2011680"/>
-            <a:ext cx="9144000" cy="914400"/>
+            <a:off x="566928" y="2148840"/>
+            <a:ext cx="7863840" cy="1005840"/>
           </a:xfrm>
           <a:prstGeom prst="rect">
             <a:avLst/>
@@ -17837,7 +17837,7 @@
               </a:spcAft>
             </a:pPr>
             <a:r>
-              <a:rPr sz="5200" b="1">
+              <a:rPr sz="5800" b="1">
                 <a:solidFill>
                   <a:srgbClr val="F0EFE9"/>
                 </a:solidFill>
@@ -17856,8 +17856,8 @@
         </p:nvSpPr>
         <p:spPr>
           <a:xfrm>
-            <a:off x="566928" y="3108960"/>
-            <a:ext cx="8778240" cy="914400"/>
+            <a:off x="566928" y="3337560"/>
+            <a:ext cx="7498079" cy="914400"/>
           </a:xfrm>
           <a:prstGeom prst="rect">
             <a:avLst/>
@@ -17872,20 +17872,21 @@
           <a:p>
             <a:pPr algn="l">
               <a:lnSpc>
-                <a:spcPct val="130000"/>
+                <a:spcPct val="135000"/>
               </a:lnSpc>
               <a:spcAft>
                 <a:spcPts val="600"/>
               </a:spcAft>
             </a:pPr>
             <a:r>
-              <a:rPr sz="2100" b="0">
+              <a:rPr sz="2400" b="0">
                 <a:solidFill>
                   <a:srgbClr val="C2C6BC"/>
                 </a:solidFill>
                 <a:latin typeface="Segoe UI"/>
               </a:rPr>
-              <a:t>A big model, on the devices you already own, with the internet switched off.</a:t>
+              <a:t>A big model, on the devices you already own,
+with the internet switched off.</a:t>
             </a:r>
           </a:p>
         </p:txBody>
@@ -17898,8 +17899,8 @@
         </p:nvSpPr>
         <p:spPr>
           <a:xfrm>
-            <a:off x="566928" y="4297680"/>
-            <a:ext cx="4754880" cy="365760"/>
+            <a:off x="566928" y="4800600"/>
+            <a:ext cx="7863840" cy="365760"/>
           </a:xfrm>
           <a:prstGeom prst="rect">
             <a:avLst/>
@@ -17924,7 +17925,7 @@
                 </a:solidFill>
                 <a:latin typeface="Segoe UI"/>
               </a:rPr>
-              <a:t>Prajwal Gunnala</a:t>
+              <a:t>Prajwal Gunnala   ·   Yuva Raj Ambati</a:t>
             </a:r>
           </a:p>
         </p:txBody>
@@ -17937,8 +17938,8 @@
         </p:nvSpPr>
         <p:spPr>
           <a:xfrm>
-            <a:off x="566928" y="4663440"/>
-            <a:ext cx="4754880" cy="274320"/>
+            <a:off x="566928" y="5257800"/>
+            <a:ext cx="7863840" cy="320040"/>
           </a:xfrm>
           <a:prstGeom prst="rect">
             <a:avLst/>
@@ -17957,9 +17958,9 @@
               </a:spcAft>
             </a:pPr>
             <a:r>
-              <a:rPr sz="1300" b="0">
+              <a:rPr sz="1500" b="0">
                 <a:solidFill>
-                  <a:srgbClr val="969C90"/>
+                  <a:srgbClr val="5FD68A"/>
                 </a:solidFill>
                 <a:latin typeface="Consolas"/>
               </a:rPr>
@@ -17971,432 +17972,6 @@
       <p:sp>
         <p:nvSpPr>
           <p:cNvPr id="33" name="TextBox 32"/>
-          <p:cNvSpPr txBox="1"/>
-          <p:nvPr/>
-        </p:nvSpPr>
-        <p:spPr>
-          <a:xfrm>
-            <a:off x="5687568" y="4297680"/>
-            <a:ext cx="4754880" cy="365760"/>
-          </a:xfrm>
-          <a:prstGeom prst="rect">
-            <a:avLst/>
-          </a:prstGeom>
-          <a:noFill/>
-        </p:spPr>
-        <p:txBody>
-          <a:bodyPr wrap="square" anchor="t" lIns="0" rIns="0" tIns="0" bIns="0">
-            <a:spAutoFit/>
-          </a:bodyPr>
-          <a:lstStyle/>
-          <a:p>
-            <a:pPr algn="l">
-              <a:spcAft>
-                <a:spcPts val="600"/>
-              </a:spcAft>
-            </a:pPr>
-            <a:r>
-              <a:rPr sz="2000" b="1">
-                <a:solidFill>
-                  <a:srgbClr val="F0EFE9"/>
-                </a:solidFill>
-                <a:latin typeface="Segoe UI"/>
-              </a:rPr>
-              <a:t>Yuva Raj Ambati</a:t>
-            </a:r>
-          </a:p>
-        </p:txBody>
-      </p:sp>
-      <p:sp>
-        <p:nvSpPr>
-          <p:cNvPr id="34" name="TextBox 33"/>
-          <p:cNvSpPr txBox="1"/>
-          <p:nvPr/>
-        </p:nvSpPr>
-        <p:spPr>
-          <a:xfrm>
-            <a:off x="5687568" y="4663440"/>
-            <a:ext cx="4754880" cy="274320"/>
-          </a:xfrm>
-          <a:prstGeom prst="rect">
-            <a:avLst/>
-          </a:prstGeom>
-          <a:noFill/>
-        </p:spPr>
-        <p:txBody>
-          <a:bodyPr wrap="square" anchor="t" lIns="0" rIns="0" tIns="0" bIns="0">
-            <a:spAutoFit/>
-          </a:bodyPr>
-          <a:lstStyle/>
-          <a:p>
-            <a:pPr algn="l">
-              <a:spcAft>
-                <a:spcPts val="600"/>
-              </a:spcAft>
-            </a:pPr>
-            <a:r>
-              <a:rPr sz="1300" b="0">
-                <a:solidFill>
-                  <a:srgbClr val="969C90"/>
-                </a:solidFill>
-                <a:latin typeface="Consolas"/>
-              </a:rPr>
-              <a:t>every number here is in that repository</a:t>
-            </a:r>
-          </a:p>
-        </p:txBody>
-      </p:sp>
-      <p:sp>
-        <p:nvSpPr>
-          <p:cNvPr id="35" name="Rounded Rectangle 34"/>
-          <p:cNvSpPr/>
-          <p:nvPr/>
-        </p:nvSpPr>
-        <p:spPr>
-          <a:xfrm>
-            <a:off x="566928" y="5394960"/>
-            <a:ext cx="2624328" cy="457200"/>
-          </a:xfrm>
-          <a:prstGeom prst="roundRect">
-            <a:avLst>
-              <a:gd name="adj" fmla="val 4000"/>
-            </a:avLst>
-          </a:prstGeom>
-          <a:solidFill>
-            <a:srgbClr val="142E20"/>
-          </a:solidFill>
-          <a:ln w="9525">
-            <a:solidFill>
-              <a:srgbClr val="5FD68A"/>
-            </a:solidFill>
-          </a:ln>
-          <a:effectLst/>
-        </p:spPr>
-        <p:style>
-          <a:lnRef idx="1">
-            <a:schemeClr val="accent1"/>
-          </a:lnRef>
-          <a:fillRef idx="3">
-            <a:schemeClr val="accent1"/>
-          </a:fillRef>
-          <a:effectRef idx="2">
-            <a:schemeClr val="accent1"/>
-          </a:effectRef>
-          <a:fontRef idx="minor">
-            <a:schemeClr val="lt1"/>
-          </a:fontRef>
-        </p:style>
-        <p:txBody>
-          <a:bodyPr rtlCol="0" anchor="ctr"/>
-          <a:lstStyle/>
-          <a:p>
-            <a:pPr algn="ctr"/>
-          </a:p>
-        </p:txBody>
-      </p:sp>
-      <p:sp>
-        <p:nvSpPr>
-          <p:cNvPr id="36" name="TextBox 35"/>
-          <p:cNvSpPr txBox="1"/>
-          <p:nvPr/>
-        </p:nvSpPr>
-        <p:spPr>
-          <a:xfrm>
-            <a:off x="566928" y="5513832"/>
-            <a:ext cx="2624328" cy="274320"/>
-          </a:xfrm>
-          <a:prstGeom prst="rect">
-            <a:avLst/>
-          </a:prstGeom>
-          <a:noFill/>
-        </p:spPr>
-        <p:txBody>
-          <a:bodyPr wrap="square" anchor="t" lIns="0" rIns="0" tIns="0" bIns="0">
-            <a:spAutoFit/>
-          </a:bodyPr>
-          <a:lstStyle/>
-          <a:p>
-            <a:pPr algn="ctr">
-              <a:spcAft>
-                <a:spcPts val="600"/>
-              </a:spcAft>
-            </a:pPr>
-            <a:r>
-              <a:rPr sz="1200" b="0">
-                <a:solidFill>
-                  <a:srgbClr val="5FD68A"/>
-                </a:solidFill>
-                <a:latin typeface="Consolas"/>
-              </a:rPr>
-              <a:t>30B across three devices</a:t>
-            </a:r>
-          </a:p>
-        </p:txBody>
-      </p:sp>
-      <p:sp>
-        <p:nvSpPr>
-          <p:cNvPr id="37" name="Rounded Rectangle 36"/>
-          <p:cNvSpPr/>
-          <p:nvPr/>
-        </p:nvSpPr>
-        <p:spPr>
-          <a:xfrm>
-            <a:off x="3378708" y="5394960"/>
-            <a:ext cx="2624328" cy="457200"/>
-          </a:xfrm>
-          <a:prstGeom prst="roundRect">
-            <a:avLst>
-              <a:gd name="adj" fmla="val 4000"/>
-            </a:avLst>
-          </a:prstGeom>
-          <a:solidFill>
-            <a:srgbClr val="142E20"/>
-          </a:solidFill>
-          <a:ln w="9525">
-            <a:solidFill>
-              <a:srgbClr val="5FD68A"/>
-            </a:solidFill>
-          </a:ln>
-          <a:effectLst/>
-        </p:spPr>
-        <p:style>
-          <a:lnRef idx="1">
-            <a:schemeClr val="accent1"/>
-          </a:lnRef>
-          <a:fillRef idx="3">
-            <a:schemeClr val="accent1"/>
-          </a:fillRef>
-          <a:effectRef idx="2">
-            <a:schemeClr val="accent1"/>
-          </a:effectRef>
-          <a:fontRef idx="minor">
-            <a:schemeClr val="lt1"/>
-          </a:fontRef>
-        </p:style>
-        <p:txBody>
-          <a:bodyPr rtlCol="0" anchor="ctr"/>
-          <a:lstStyle/>
-          <a:p>
-            <a:pPr algn="ctr"/>
-          </a:p>
-        </p:txBody>
-      </p:sp>
-      <p:sp>
-        <p:nvSpPr>
-          <p:cNvPr id="38" name="TextBox 37"/>
-          <p:cNvSpPr txBox="1"/>
-          <p:nvPr/>
-        </p:nvSpPr>
-        <p:spPr>
-          <a:xfrm>
-            <a:off x="3378708" y="5513832"/>
-            <a:ext cx="2624328" cy="274320"/>
-          </a:xfrm>
-          <a:prstGeom prst="rect">
-            <a:avLst/>
-          </a:prstGeom>
-          <a:noFill/>
-        </p:spPr>
-        <p:txBody>
-          <a:bodyPr wrap="square" anchor="t" lIns="0" rIns="0" tIns="0" bIns="0">
-            <a:spAutoFit/>
-          </a:bodyPr>
-          <a:lstStyle/>
-          <a:p>
-            <a:pPr algn="ctr">
-              <a:spcAft>
-                <a:spcPts val="600"/>
-              </a:spcAft>
-            </a:pPr>
-            <a:r>
-              <a:rPr sz="1200" b="0">
-                <a:solidFill>
-                  <a:srgbClr val="5FD68A"/>
-                </a:solidFill>
-                <a:latin typeface="Consolas"/>
-              </a:rPr>
-              <a:t>ready in 70 s</a:t>
-            </a:r>
-          </a:p>
-        </p:txBody>
-      </p:sp>
-      <p:sp>
-        <p:nvSpPr>
-          <p:cNvPr id="39" name="Rounded Rectangle 38"/>
-          <p:cNvSpPr/>
-          <p:nvPr/>
-        </p:nvSpPr>
-        <p:spPr>
-          <a:xfrm>
-            <a:off x="6190488" y="5394960"/>
-            <a:ext cx="2624328" cy="457200"/>
-          </a:xfrm>
-          <a:prstGeom prst="roundRect">
-            <a:avLst>
-              <a:gd name="adj" fmla="val 4000"/>
-            </a:avLst>
-          </a:prstGeom>
-          <a:solidFill>
-            <a:srgbClr val="142E20"/>
-          </a:solidFill>
-          <a:ln w="9525">
-            <a:solidFill>
-              <a:srgbClr val="5FD68A"/>
-            </a:solidFill>
-          </a:ln>
-          <a:effectLst/>
-        </p:spPr>
-        <p:style>
-          <a:lnRef idx="1">
-            <a:schemeClr val="accent1"/>
-          </a:lnRef>
-          <a:fillRef idx="3">
-            <a:schemeClr val="accent1"/>
-          </a:fillRef>
-          <a:effectRef idx="2">
-            <a:schemeClr val="accent1"/>
-          </a:effectRef>
-          <a:fontRef idx="minor">
-            <a:schemeClr val="lt1"/>
-          </a:fontRef>
-        </p:style>
-        <p:txBody>
-          <a:bodyPr rtlCol="0" anchor="ctr"/>
-          <a:lstStyle/>
-          <a:p>
-            <a:pPr algn="ctr"/>
-          </a:p>
-        </p:txBody>
-      </p:sp>
-      <p:sp>
-        <p:nvSpPr>
-          <p:cNvPr id="40" name="TextBox 39"/>
-          <p:cNvSpPr txBox="1"/>
-          <p:nvPr/>
-        </p:nvSpPr>
-        <p:spPr>
-          <a:xfrm>
-            <a:off x="6190488" y="5513832"/>
-            <a:ext cx="2624328" cy="274320"/>
-          </a:xfrm>
-          <a:prstGeom prst="rect">
-            <a:avLst/>
-          </a:prstGeom>
-          <a:noFill/>
-        </p:spPr>
-        <p:txBody>
-          <a:bodyPr wrap="square" anchor="t" lIns="0" rIns="0" tIns="0" bIns="0">
-            <a:spAutoFit/>
-          </a:bodyPr>
-          <a:lstStyle/>
-          <a:p>
-            <a:pPr algn="ctr">
-              <a:spcAft>
-                <a:spcPts val="600"/>
-              </a:spcAft>
-            </a:pPr>
-            <a:r>
-              <a:rPr sz="1200" b="0">
-                <a:solidFill>
-                  <a:srgbClr val="5FD68A"/>
-                </a:solidFill>
-                <a:latin typeface="Consolas"/>
-              </a:rPr>
-              <a:t>6.6 words a second</a:t>
-            </a:r>
-          </a:p>
-        </p:txBody>
-      </p:sp>
-      <p:sp>
-        <p:nvSpPr>
-          <p:cNvPr id="41" name="Rounded Rectangle 40"/>
-          <p:cNvSpPr/>
-          <p:nvPr/>
-        </p:nvSpPr>
-        <p:spPr>
-          <a:xfrm>
-            <a:off x="9002268" y="5394960"/>
-            <a:ext cx="2624328" cy="457200"/>
-          </a:xfrm>
-          <a:prstGeom prst="roundRect">
-            <a:avLst>
-              <a:gd name="adj" fmla="val 4000"/>
-            </a:avLst>
-          </a:prstGeom>
-          <a:solidFill>
-            <a:srgbClr val="142E20"/>
-          </a:solidFill>
-          <a:ln w="9525">
-            <a:solidFill>
-              <a:srgbClr val="5FD68A"/>
-            </a:solidFill>
-          </a:ln>
-          <a:effectLst/>
-        </p:spPr>
-        <p:style>
-          <a:lnRef idx="1">
-            <a:schemeClr val="accent1"/>
-          </a:lnRef>
-          <a:fillRef idx="3">
-            <a:schemeClr val="accent1"/>
-          </a:fillRef>
-          <a:effectRef idx="2">
-            <a:schemeClr val="accent1"/>
-          </a:effectRef>
-          <a:fontRef idx="minor">
-            <a:schemeClr val="lt1"/>
-          </a:fontRef>
-        </p:style>
-        <p:txBody>
-          <a:bodyPr rtlCol="0" anchor="ctr"/>
-          <a:lstStyle/>
-          <a:p>
-            <a:pPr algn="ctr"/>
-          </a:p>
-        </p:txBody>
-      </p:sp>
-      <p:sp>
-        <p:nvSpPr>
-          <p:cNvPr id="42" name="TextBox 41"/>
-          <p:cNvSpPr txBox="1"/>
-          <p:nvPr/>
-        </p:nvSpPr>
-        <p:spPr>
-          <a:xfrm>
-            <a:off x="9002268" y="5513832"/>
-            <a:ext cx="2624328" cy="274320"/>
-          </a:xfrm>
-          <a:prstGeom prst="rect">
-            <a:avLst/>
-          </a:prstGeom>
-          <a:noFill/>
-        </p:spPr>
-        <p:txBody>
-          <a:bodyPr wrap="square" anchor="t" lIns="0" rIns="0" tIns="0" bIns="0">
-            <a:spAutoFit/>
-          </a:bodyPr>
-          <a:lstStyle/>
-          <a:p>
-            <a:pPr algn="ctr">
-              <a:spcAft>
-                <a:spcPts val="600"/>
-              </a:spcAft>
-            </a:pPr>
-            <a:r>
-              <a:rPr sz="1200" b="0">
-                <a:solidFill>
-                  <a:srgbClr val="5FD68A"/>
-                </a:solidFill>
-                <a:latin typeface="Consolas"/>
-              </a:rPr>
-              <a:t>internet off</a:t>
-            </a:r>
-          </a:p>
-        </p:txBody>
-      </p:sp>
-      <p:sp>
-        <p:nvSpPr>
-          <p:cNvPr id="43" name="TextBox 42"/>
           <p:cNvSpPr txBox="1"/>
           <p:nvPr/>
         </p:nvSpPr>
@@ -18435,7 +18010,7 @@
       </p:sp>
       <p:sp>
         <p:nvSpPr>
-          <p:cNvPr id="44" name="TextBox 43"/>
+          <p:cNvPr id="34" name="TextBox 33"/>
           <p:cNvSpPr txBox="1"/>
           <p:nvPr/>
         </p:nvSpPr>

</xml_diff>